<commit_message>
Update PowerPoint for song #220 in FUBC - Українські
</commit_message>
<xml_diff>
--- a/fubc-ua/220-Струн душі рука Христа торкається (Пісні Спасенних №218).pptx
+++ b/fubc-ua/220-Струн душі рука Христа торкається (Пісні Спасенних №218).pptx
@@ -1664,7 +1664,7 @@
         </p:nvSpPr>
         <p:spPr>
           <a:xfrm>
-            <a:off x="1022223" y="3547872"/>
+            <a:off x="1121283" y="3547872"/>
             <a:ext cx="0" cy="2179320"/>
           </a:xfrm>
           <a:prstGeom prst="line">
@@ -1687,7 +1687,7 @@
         </p:nvSpPr>
         <p:spPr>
           <a:xfrm>
-            <a:off x="11175873" y="3547872"/>
+            <a:off x="11076813" y="3547872"/>
             <a:ext cx="0" cy="2179320"/>
           </a:xfrm>
           <a:prstGeom prst="line">
@@ -1710,8 +1710,8 @@
         </p:nvSpPr>
         <p:spPr>
           <a:xfrm>
-            <a:off x="11307953" y="4406392"/>
-            <a:ext cx="792480" cy="462280"/>
+            <a:off x="11175873" y="4317492"/>
+            <a:ext cx="1097280" cy="640080"/>
           </a:xfrm>
           <a:prstGeom prst="rect">
             <a:avLst/>
@@ -1727,9 +1727,9 @@
               <a:buNone/>
             </a:pPr>
             <a:r>
-              <a:rPr lang="en-US" sz="2600" b="1" dirty="0">
-                <a:solidFill>
-                  <a:srgbClr val="8A8A8A"/>
+              <a:rPr lang="en-US" sz="3600" b="1" dirty="0">
+                <a:solidFill>
+                  <a:srgbClr val="BBBBBB"/>
                 </a:solidFill>
                 <a:latin typeface="Arial" pitchFamily="34" charset="0"/>
                 <a:ea typeface="Arial" pitchFamily="34" charset="-122"/>
@@ -1737,7 +1737,7 @@
               </a:rPr>
               <a:t>×2</a:t>
             </a:r>
-            <a:endParaRPr lang="en-US" sz="2600" dirty="0"/>
+            <a:endParaRPr lang="en-US" sz="3600" dirty="0"/>
           </a:p>
         </p:txBody>
       </p:sp>
@@ -1903,7 +1903,7 @@
         </p:nvSpPr>
         <p:spPr>
           <a:xfrm>
-            <a:off x="1209446" y="3151632"/>
+            <a:off x="1308506" y="3151632"/>
             <a:ext cx="0" cy="2179320"/>
           </a:xfrm>
           <a:prstGeom prst="line">
@@ -1926,7 +1926,7 @@
         </p:nvSpPr>
         <p:spPr>
           <a:xfrm>
-            <a:off x="10988650" y="3151632"/>
+            <a:off x="10889590" y="3151632"/>
             <a:ext cx="0" cy="2179320"/>
           </a:xfrm>
           <a:prstGeom prst="line">
@@ -1949,8 +1949,8 @@
         </p:nvSpPr>
         <p:spPr>
           <a:xfrm>
-            <a:off x="11120730" y="4010152"/>
-            <a:ext cx="792480" cy="462280"/>
+            <a:off x="10988650" y="3921252"/>
+            <a:ext cx="1097280" cy="640080"/>
           </a:xfrm>
           <a:prstGeom prst="rect">
             <a:avLst/>
@@ -1966,9 +1966,9 @@
               <a:buNone/>
             </a:pPr>
             <a:r>
-              <a:rPr lang="en-US" sz="2600" b="1" dirty="0">
-                <a:solidFill>
-                  <a:srgbClr val="8A8A8A"/>
+              <a:rPr lang="en-US" sz="3600" b="1" dirty="0">
+                <a:solidFill>
+                  <a:srgbClr val="BBBBBB"/>
                 </a:solidFill>
                 <a:latin typeface="Arial" pitchFamily="34" charset="0"/>
                 <a:ea typeface="Arial" pitchFamily="34" charset="-122"/>
@@ -1976,7 +1976,7 @@
               </a:rPr>
               <a:t>×2</a:t>
             </a:r>
-            <a:endParaRPr lang="en-US" sz="2600" dirty="0"/>
+            <a:endParaRPr lang="en-US" sz="3600" dirty="0"/>
           </a:p>
         </p:txBody>
       </p:sp>
@@ -2162,7 +2162,7 @@
         </p:nvSpPr>
         <p:spPr>
           <a:xfrm>
-            <a:off x="2563927" y="2755392"/>
+            <a:off x="2662987" y="2755392"/>
             <a:ext cx="0" cy="2971800"/>
           </a:xfrm>
           <a:prstGeom prst="line">
@@ -2185,7 +2185,7 @@
         </p:nvSpPr>
         <p:spPr>
           <a:xfrm>
-            <a:off x="9634169" y="2755392"/>
+            <a:off x="9535109" y="2755392"/>
             <a:ext cx="0" cy="2971800"/>
           </a:xfrm>
           <a:prstGeom prst="line">
@@ -2208,8 +2208,8 @@
         </p:nvSpPr>
         <p:spPr>
           <a:xfrm>
-            <a:off x="9766249" y="4010152"/>
-            <a:ext cx="792480" cy="462280"/>
+            <a:off x="9634169" y="3921252"/>
+            <a:ext cx="1097280" cy="640080"/>
           </a:xfrm>
           <a:prstGeom prst="rect">
             <a:avLst/>
@@ -2225,9 +2225,9 @@
               <a:buNone/>
             </a:pPr>
             <a:r>
-              <a:rPr lang="en-US" sz="2600" b="1" dirty="0">
-                <a:solidFill>
-                  <a:srgbClr val="8A8A8A"/>
+              <a:rPr lang="en-US" sz="3600" b="1" dirty="0">
+                <a:solidFill>
+                  <a:srgbClr val="BBBBBB"/>
                 </a:solidFill>
                 <a:latin typeface="Arial" pitchFamily="34" charset="0"/>
                 <a:ea typeface="Arial" pitchFamily="34" charset="-122"/>
@@ -2235,7 +2235,7 @@
               </a:rPr>
               <a:t>×2</a:t>
             </a:r>
-            <a:endParaRPr lang="en-US" sz="2600" dirty="0"/>
+            <a:endParaRPr lang="en-US" sz="3600" dirty="0"/>
           </a:p>
         </p:txBody>
       </p:sp>
@@ -2421,7 +2421,7 @@
         </p:nvSpPr>
         <p:spPr>
           <a:xfrm>
-            <a:off x="2902382" y="2755392"/>
+            <a:off x="3001442" y="2755392"/>
             <a:ext cx="0" cy="2971800"/>
           </a:xfrm>
           <a:prstGeom prst="line">
@@ -2444,7 +2444,7 @@
         </p:nvSpPr>
         <p:spPr>
           <a:xfrm>
-            <a:off x="9295714" y="2755392"/>
+            <a:off x="9196654" y="2755392"/>
             <a:ext cx="0" cy="2971800"/>
           </a:xfrm>
           <a:prstGeom prst="line">
@@ -2467,8 +2467,8 @@
         </p:nvSpPr>
         <p:spPr>
           <a:xfrm>
-            <a:off x="9427794" y="4010152"/>
-            <a:ext cx="792480" cy="462280"/>
+            <a:off x="9295714" y="3921252"/>
+            <a:ext cx="1097280" cy="640080"/>
           </a:xfrm>
           <a:prstGeom prst="rect">
             <a:avLst/>
@@ -2484,9 +2484,9 @@
               <a:buNone/>
             </a:pPr>
             <a:r>
-              <a:rPr lang="en-US" sz="2600" b="1" dirty="0">
-                <a:solidFill>
-                  <a:srgbClr val="8A8A8A"/>
+              <a:rPr lang="en-US" sz="3600" b="1" dirty="0">
+                <a:solidFill>
+                  <a:srgbClr val="BBBBBB"/>
                 </a:solidFill>
                 <a:latin typeface="Arial" pitchFamily="34" charset="0"/>
                 <a:ea typeface="Arial" pitchFamily="34" charset="-122"/>
@@ -2494,7 +2494,7 @@
               </a:rPr>
               <a:t>×2</a:t>
             </a:r>
-            <a:endParaRPr lang="en-US" sz="2600" dirty="0"/>
+            <a:endParaRPr lang="en-US" sz="3600" dirty="0"/>
           </a:p>
         </p:txBody>
       </p:sp>
@@ -2700,7 +2700,7 @@
         </p:nvSpPr>
         <p:spPr>
           <a:xfrm>
-            <a:off x="3009036" y="3151632"/>
+            <a:off x="3108096" y="3151632"/>
             <a:ext cx="0" cy="2971800"/>
           </a:xfrm>
           <a:prstGeom prst="line">
@@ -2723,7 +2723,7 @@
         </p:nvSpPr>
         <p:spPr>
           <a:xfrm>
-            <a:off x="9189060" y="3151632"/>
+            <a:off x="9090000" y="3151632"/>
             <a:ext cx="0" cy="2971800"/>
           </a:xfrm>
           <a:prstGeom prst="line">
@@ -2746,8 +2746,8 @@
         </p:nvSpPr>
         <p:spPr>
           <a:xfrm>
-            <a:off x="9321140" y="4406392"/>
-            <a:ext cx="792480" cy="462280"/>
+            <a:off x="9189060" y="4317492"/>
+            <a:ext cx="1097280" cy="640080"/>
           </a:xfrm>
           <a:prstGeom prst="rect">
             <a:avLst/>
@@ -2763,9 +2763,9 @@
               <a:buNone/>
             </a:pPr>
             <a:r>
-              <a:rPr lang="en-US" sz="2600" b="1" dirty="0">
-                <a:solidFill>
-                  <a:srgbClr val="8A8A8A"/>
+              <a:rPr lang="en-US" sz="3600" b="1" dirty="0">
+                <a:solidFill>
+                  <a:srgbClr val="BBBBBB"/>
                 </a:solidFill>
                 <a:latin typeface="Arial" pitchFamily="34" charset="0"/>
                 <a:ea typeface="Arial" pitchFamily="34" charset="-122"/>
@@ -2773,7 +2773,7 @@
               </a:rPr>
               <a:t>×2</a:t>
             </a:r>
-            <a:endParaRPr lang="en-US" sz="2600" dirty="0"/>
+            <a:endParaRPr lang="en-US" sz="3600" dirty="0"/>
           </a:p>
         </p:txBody>
       </p:sp>

</xml_diff>